<commit_message>
solid prensiplere göre düzenlemeler yapılıyor.
</commit_message>
<xml_diff>
--- a/8_Design_Patterns_EVERY_Developer_Should_Know.pptx
+++ b/8_Design_Patterns_EVERY_Developer_Should_Know.pptx
@@ -15,32 +15,6 @@
     <p:sldId id="263" r:id="rId14"/>
     <p:sldId id="264" r:id="rId15"/>
     <p:sldId id="265" r:id="rId16"/>
-    <p:sldId id="266" r:id="rId17"/>
-    <p:sldId id="267" r:id="rId18"/>
-    <p:sldId id="268" r:id="rId19"/>
-    <p:sldId id="269" r:id="rId20"/>
-    <p:sldId id="270" r:id="rId21"/>
-    <p:sldId id="271" r:id="rId22"/>
-    <p:sldId id="272" r:id="rId23"/>
-    <p:sldId id="273" r:id="rId24"/>
-    <p:sldId id="274" r:id="rId25"/>
-    <p:sldId id="275" r:id="rId26"/>
-    <p:sldId id="276" r:id="rId27"/>
-    <p:sldId id="277" r:id="rId28"/>
-    <p:sldId id="278" r:id="rId29"/>
-    <p:sldId id="279" r:id="rId30"/>
-    <p:sldId id="280" r:id="rId31"/>
-    <p:sldId id="281" r:id="rId32"/>
-    <p:sldId id="282" r:id="rId33"/>
-    <p:sldId id="283" r:id="rId34"/>
-    <p:sldId id="284" r:id="rId35"/>
-    <p:sldId id="285" r:id="rId36"/>
-    <p:sldId id="286" r:id="rId37"/>
-    <p:sldId id="287" r:id="rId38"/>
-    <p:sldId id="288" r:id="rId39"/>
-    <p:sldId id="289" r:id="rId40"/>
-    <p:sldId id="290" r:id="rId41"/>
-    <p:sldId id="291" r:id="rId42"/>
   </p:sldIdLst>
   <p:sldSz cx="9144000" cy="6858000" type="screen4x3"/>
   <p:notesSz cx="6858000" cy="9144000"/>
@@ -3244,637 +3218,7 @@
           <a:lstStyle/>
           <a:p>
             <a:r>
-              <a:t>8 Design Patterns EVERY Developer Should Know - 08:32:000</a:t>
-            </a:r>
-          </a:p>
-        </p:txBody>
-      </p:sp>
-    </p:spTree>
-  </p:cSld>
-  <p:clrMapOvr>
-    <a:masterClrMapping/>
-  </p:clrMapOvr>
-</p:sld>
-</file>
-
-<file path=ppt/slides/slide11.xml><?xml version="1.0" encoding="utf-8"?>
-<p:sld xmlns:a="http://schemas.openxmlformats.org/drawingml/2006/main" xmlns:p="http://schemas.openxmlformats.org/presentationml/2006/main" xmlns:r="http://schemas.openxmlformats.org/officeDocument/2006/relationships">
-  <p:cSld>
-    <p:spTree>
-      <p:nvGrpSpPr>
-        <p:cNvPr id="1" name=""/>
-        <p:cNvGrpSpPr/>
-        <p:nvPr/>
-      </p:nvGrpSpPr>
-      <p:grpSpPr/>
-      <p:pic>
-        <p:nvPicPr>
-          <p:cNvPr id="2" name="Picture 1" descr="image.jpg"/>
-          <p:cNvPicPr>
-            <a:picLocks noChangeAspect="1"/>
-          </p:cNvPicPr>
-          <p:nvPr/>
-        </p:nvPicPr>
-        <p:blipFill>
-          <a:blip r:embed="rId2"/>
-          <a:stretch>
-            <a:fillRect/>
-          </a:stretch>
-        </p:blipFill>
-        <p:spPr>
-          <a:xfrm>
-            <a:off x="1523999" y="1371600"/>
-            <a:ext cx="6096000" cy="3429000"/>
-          </a:xfrm>
-          <a:prstGeom prst="rect">
-            <a:avLst/>
-          </a:prstGeom>
-        </p:spPr>
-      </p:pic>
-      <p:sp>
-        <p:nvSpPr>
-          <p:cNvPr id="3" name="TextBox 2"/>
-          <p:cNvSpPr txBox="1"/>
-          <p:nvPr/>
-        </p:nvSpPr>
-        <p:spPr>
-          <a:xfrm>
-            <a:off x="914400" y="5943600"/>
-            <a:ext cx="7315200" cy="914400"/>
-          </a:xfrm>
-          <a:prstGeom prst="rect">
-            <a:avLst/>
-          </a:prstGeom>
-          <a:noFill/>
-        </p:spPr>
-        <p:txBody>
-          <a:bodyPr wrap="none">
-            <a:spAutoFit/>
-          </a:bodyPr>
-          <a:lstStyle/>
-          <a:p>
-            <a:r>
-              <a:t>8 Design Patterns EVERY Developer Should Know - 08:34:000</a:t>
-            </a:r>
-          </a:p>
-        </p:txBody>
-      </p:sp>
-    </p:spTree>
-  </p:cSld>
-  <p:clrMapOvr>
-    <a:masterClrMapping/>
-  </p:clrMapOvr>
-</p:sld>
-</file>
-
-<file path=ppt/slides/slide12.xml><?xml version="1.0" encoding="utf-8"?>
-<p:sld xmlns:a="http://schemas.openxmlformats.org/drawingml/2006/main" xmlns:p="http://schemas.openxmlformats.org/presentationml/2006/main" xmlns:r="http://schemas.openxmlformats.org/officeDocument/2006/relationships">
-  <p:cSld>
-    <p:spTree>
-      <p:nvGrpSpPr>
-        <p:cNvPr id="1" name=""/>
-        <p:cNvGrpSpPr/>
-        <p:nvPr/>
-      </p:nvGrpSpPr>
-      <p:grpSpPr/>
-      <p:pic>
-        <p:nvPicPr>
-          <p:cNvPr id="2" name="Picture 1" descr="image.jpg"/>
-          <p:cNvPicPr>
-            <a:picLocks noChangeAspect="1"/>
-          </p:cNvPicPr>
-          <p:nvPr/>
-        </p:nvPicPr>
-        <p:blipFill>
-          <a:blip r:embed="rId2"/>
-          <a:stretch>
-            <a:fillRect/>
-          </a:stretch>
-        </p:blipFill>
-        <p:spPr>
-          <a:xfrm>
-            <a:off x="1523999" y="1371600"/>
-            <a:ext cx="6096000" cy="3429000"/>
-          </a:xfrm>
-          <a:prstGeom prst="rect">
-            <a:avLst/>
-          </a:prstGeom>
-        </p:spPr>
-      </p:pic>
-      <p:sp>
-        <p:nvSpPr>
-          <p:cNvPr id="3" name="TextBox 2"/>
-          <p:cNvSpPr txBox="1"/>
-          <p:nvPr/>
-        </p:nvSpPr>
-        <p:spPr>
-          <a:xfrm>
-            <a:off x="914400" y="5943600"/>
-            <a:ext cx="7315200" cy="914400"/>
-          </a:xfrm>
-          <a:prstGeom prst="rect">
-            <a:avLst/>
-          </a:prstGeom>
-          <a:noFill/>
-        </p:spPr>
-        <p:txBody>
-          <a:bodyPr wrap="none">
-            <a:spAutoFit/>
-          </a:bodyPr>
-          <a:lstStyle/>
-          <a:p>
-            <a:r>
-              <a:t>8 Design Patterns EVERY Developer Should Know - 08:37:000</a:t>
-            </a:r>
-          </a:p>
-        </p:txBody>
-      </p:sp>
-    </p:spTree>
-  </p:cSld>
-  <p:clrMapOvr>
-    <a:masterClrMapping/>
-  </p:clrMapOvr>
-</p:sld>
-</file>
-
-<file path=ppt/slides/slide13.xml><?xml version="1.0" encoding="utf-8"?>
-<p:sld xmlns:a="http://schemas.openxmlformats.org/drawingml/2006/main" xmlns:p="http://schemas.openxmlformats.org/presentationml/2006/main" xmlns:r="http://schemas.openxmlformats.org/officeDocument/2006/relationships">
-  <p:cSld>
-    <p:spTree>
-      <p:nvGrpSpPr>
-        <p:cNvPr id="1" name=""/>
-        <p:cNvGrpSpPr/>
-        <p:nvPr/>
-      </p:nvGrpSpPr>
-      <p:grpSpPr/>
-      <p:pic>
-        <p:nvPicPr>
-          <p:cNvPr id="2" name="Picture 1" descr="image.jpg"/>
-          <p:cNvPicPr>
-            <a:picLocks noChangeAspect="1"/>
-          </p:cNvPicPr>
-          <p:nvPr/>
-        </p:nvPicPr>
-        <p:blipFill>
-          <a:blip r:embed="rId2"/>
-          <a:stretch>
-            <a:fillRect/>
-          </a:stretch>
-        </p:blipFill>
-        <p:spPr>
-          <a:xfrm>
-            <a:off x="1523999" y="1371600"/>
-            <a:ext cx="6096000" cy="3429000"/>
-          </a:xfrm>
-          <a:prstGeom prst="rect">
-            <a:avLst/>
-          </a:prstGeom>
-        </p:spPr>
-      </p:pic>
-      <p:sp>
-        <p:nvSpPr>
-          <p:cNvPr id="3" name="TextBox 2"/>
-          <p:cNvSpPr txBox="1"/>
-          <p:nvPr/>
-        </p:nvSpPr>
-        <p:spPr>
-          <a:xfrm>
-            <a:off x="914400" y="5943600"/>
-            <a:ext cx="7315200" cy="914400"/>
-          </a:xfrm>
-          <a:prstGeom prst="rect">
-            <a:avLst/>
-          </a:prstGeom>
-          <a:noFill/>
-        </p:spPr>
-        <p:txBody>
-          <a:bodyPr wrap="none">
-            <a:spAutoFit/>
-          </a:bodyPr>
-          <a:lstStyle/>
-          <a:p>
-            <a:r>
-              <a:t>8 Design Patterns EVERY Developer Should Know - 08:49:000</a:t>
-            </a:r>
-          </a:p>
-        </p:txBody>
-      </p:sp>
-    </p:spTree>
-  </p:cSld>
-  <p:clrMapOvr>
-    <a:masterClrMapping/>
-  </p:clrMapOvr>
-</p:sld>
-</file>
-
-<file path=ppt/slides/slide14.xml><?xml version="1.0" encoding="utf-8"?>
-<p:sld xmlns:a="http://schemas.openxmlformats.org/drawingml/2006/main" xmlns:p="http://schemas.openxmlformats.org/presentationml/2006/main" xmlns:r="http://schemas.openxmlformats.org/officeDocument/2006/relationships">
-  <p:cSld>
-    <p:spTree>
-      <p:nvGrpSpPr>
-        <p:cNvPr id="1" name=""/>
-        <p:cNvGrpSpPr/>
-        <p:nvPr/>
-      </p:nvGrpSpPr>
-      <p:grpSpPr/>
-      <p:pic>
-        <p:nvPicPr>
-          <p:cNvPr id="2" name="Picture 1" descr="image.jpg"/>
-          <p:cNvPicPr>
-            <a:picLocks noChangeAspect="1"/>
-          </p:cNvPicPr>
-          <p:nvPr/>
-        </p:nvPicPr>
-        <p:blipFill>
-          <a:blip r:embed="rId2"/>
-          <a:stretch>
-            <a:fillRect/>
-          </a:stretch>
-        </p:blipFill>
-        <p:spPr>
-          <a:xfrm>
-            <a:off x="1523999" y="1371600"/>
-            <a:ext cx="6096000" cy="3429000"/>
-          </a:xfrm>
-          <a:prstGeom prst="rect">
-            <a:avLst/>
-          </a:prstGeom>
-        </p:spPr>
-      </p:pic>
-      <p:sp>
-        <p:nvSpPr>
-          <p:cNvPr id="3" name="TextBox 2"/>
-          <p:cNvSpPr txBox="1"/>
-          <p:nvPr/>
-        </p:nvSpPr>
-        <p:spPr>
-          <a:xfrm>
-            <a:off x="914400" y="5943600"/>
-            <a:ext cx="7315200" cy="914400"/>
-          </a:xfrm>
-          <a:prstGeom prst="rect">
-            <a:avLst/>
-          </a:prstGeom>
-          <a:noFill/>
-        </p:spPr>
-        <p:txBody>
-          <a:bodyPr wrap="none">
-            <a:spAutoFit/>
-          </a:bodyPr>
-          <a:lstStyle/>
-          <a:p>
-            <a:r>
-              <a:t>8 Design Patterns EVERY Developer Should Know - 08:59:000</a:t>
-            </a:r>
-          </a:p>
-        </p:txBody>
-      </p:sp>
-    </p:spTree>
-  </p:cSld>
-  <p:clrMapOvr>
-    <a:masterClrMapping/>
-  </p:clrMapOvr>
-</p:sld>
-</file>
-
-<file path=ppt/slides/slide15.xml><?xml version="1.0" encoding="utf-8"?>
-<p:sld xmlns:a="http://schemas.openxmlformats.org/drawingml/2006/main" xmlns:p="http://schemas.openxmlformats.org/presentationml/2006/main" xmlns:r="http://schemas.openxmlformats.org/officeDocument/2006/relationships">
-  <p:cSld>
-    <p:spTree>
-      <p:nvGrpSpPr>
-        <p:cNvPr id="1" name=""/>
-        <p:cNvGrpSpPr/>
-        <p:nvPr/>
-      </p:nvGrpSpPr>
-      <p:grpSpPr/>
-      <p:pic>
-        <p:nvPicPr>
-          <p:cNvPr id="2" name="Picture 1" descr="image.jpg"/>
-          <p:cNvPicPr>
-            <a:picLocks noChangeAspect="1"/>
-          </p:cNvPicPr>
-          <p:nvPr/>
-        </p:nvPicPr>
-        <p:blipFill>
-          <a:blip r:embed="rId2"/>
-          <a:stretch>
-            <a:fillRect/>
-          </a:stretch>
-        </p:blipFill>
-        <p:spPr>
-          <a:xfrm>
-            <a:off x="1523999" y="1371600"/>
-            <a:ext cx="6096000" cy="3429000"/>
-          </a:xfrm>
-          <a:prstGeom prst="rect">
-            <a:avLst/>
-          </a:prstGeom>
-        </p:spPr>
-      </p:pic>
-      <p:sp>
-        <p:nvSpPr>
-          <p:cNvPr id="3" name="TextBox 2"/>
-          <p:cNvSpPr txBox="1"/>
-          <p:nvPr/>
-        </p:nvSpPr>
-        <p:spPr>
-          <a:xfrm>
-            <a:off x="914400" y="5943600"/>
-            <a:ext cx="7315200" cy="914400"/>
-          </a:xfrm>
-          <a:prstGeom prst="rect">
-            <a:avLst/>
-          </a:prstGeom>
-          <a:noFill/>
-        </p:spPr>
-        <p:txBody>
-          <a:bodyPr wrap="none">
-            <a:spAutoFit/>
-          </a:bodyPr>
-          <a:lstStyle/>
-          <a:p>
-            <a:r>
-              <a:t>8 Design Patterns EVERY Developer Should Know - 09:00:000</a:t>
-            </a:r>
-          </a:p>
-        </p:txBody>
-      </p:sp>
-    </p:spTree>
-  </p:cSld>
-  <p:clrMapOvr>
-    <a:masterClrMapping/>
-  </p:clrMapOvr>
-</p:sld>
-</file>
-
-<file path=ppt/slides/slide16.xml><?xml version="1.0" encoding="utf-8"?>
-<p:sld xmlns:a="http://schemas.openxmlformats.org/drawingml/2006/main" xmlns:p="http://schemas.openxmlformats.org/presentationml/2006/main" xmlns:r="http://schemas.openxmlformats.org/officeDocument/2006/relationships">
-  <p:cSld>
-    <p:spTree>
-      <p:nvGrpSpPr>
-        <p:cNvPr id="1" name=""/>
-        <p:cNvGrpSpPr/>
-        <p:nvPr/>
-      </p:nvGrpSpPr>
-      <p:grpSpPr/>
-      <p:pic>
-        <p:nvPicPr>
-          <p:cNvPr id="2" name="Picture 1" descr="image.jpg"/>
-          <p:cNvPicPr>
-            <a:picLocks noChangeAspect="1"/>
-          </p:cNvPicPr>
-          <p:nvPr/>
-        </p:nvPicPr>
-        <p:blipFill>
-          <a:blip r:embed="rId2"/>
-          <a:stretch>
-            <a:fillRect/>
-          </a:stretch>
-        </p:blipFill>
-        <p:spPr>
-          <a:xfrm>
-            <a:off x="1523999" y="1371600"/>
-            <a:ext cx="6096000" cy="3429000"/>
-          </a:xfrm>
-          <a:prstGeom prst="rect">
-            <a:avLst/>
-          </a:prstGeom>
-        </p:spPr>
-      </p:pic>
-      <p:sp>
-        <p:nvSpPr>
-          <p:cNvPr id="3" name="TextBox 2"/>
-          <p:cNvSpPr txBox="1"/>
-          <p:nvPr/>
-        </p:nvSpPr>
-        <p:spPr>
-          <a:xfrm>
-            <a:off x="914400" y="5943600"/>
-            <a:ext cx="7315200" cy="914400"/>
-          </a:xfrm>
-          <a:prstGeom prst="rect">
-            <a:avLst/>
-          </a:prstGeom>
-          <a:noFill/>
-        </p:spPr>
-        <p:txBody>
-          <a:bodyPr wrap="none">
-            <a:spAutoFit/>
-          </a:bodyPr>
-          <a:lstStyle/>
-          <a:p>
-            <a:r>
-              <a:t>8 Design Patterns EVERY Developer Should Know - 09:02:000</a:t>
-            </a:r>
-          </a:p>
-        </p:txBody>
-      </p:sp>
-    </p:spTree>
-  </p:cSld>
-  <p:clrMapOvr>
-    <a:masterClrMapping/>
-  </p:clrMapOvr>
-</p:sld>
-</file>
-
-<file path=ppt/slides/slide17.xml><?xml version="1.0" encoding="utf-8"?>
-<p:sld xmlns:a="http://schemas.openxmlformats.org/drawingml/2006/main" xmlns:p="http://schemas.openxmlformats.org/presentationml/2006/main" xmlns:r="http://schemas.openxmlformats.org/officeDocument/2006/relationships">
-  <p:cSld>
-    <p:spTree>
-      <p:nvGrpSpPr>
-        <p:cNvPr id="1" name=""/>
-        <p:cNvGrpSpPr/>
-        <p:nvPr/>
-      </p:nvGrpSpPr>
-      <p:grpSpPr/>
-      <p:pic>
-        <p:nvPicPr>
-          <p:cNvPr id="2" name="Picture 1" descr="image.jpg"/>
-          <p:cNvPicPr>
-            <a:picLocks noChangeAspect="1"/>
-          </p:cNvPicPr>
-          <p:nvPr/>
-        </p:nvPicPr>
-        <p:blipFill>
-          <a:blip r:embed="rId2"/>
-          <a:stretch>
-            <a:fillRect/>
-          </a:stretch>
-        </p:blipFill>
-        <p:spPr>
-          <a:xfrm>
-            <a:off x="1523999" y="1371600"/>
-            <a:ext cx="6096000" cy="3429000"/>
-          </a:xfrm>
-          <a:prstGeom prst="rect">
-            <a:avLst/>
-          </a:prstGeom>
-        </p:spPr>
-      </p:pic>
-      <p:sp>
-        <p:nvSpPr>
-          <p:cNvPr id="3" name="TextBox 2"/>
-          <p:cNvSpPr txBox="1"/>
-          <p:nvPr/>
-        </p:nvSpPr>
-        <p:spPr>
-          <a:xfrm>
-            <a:off x="914400" y="5943600"/>
-            <a:ext cx="7315200" cy="914400"/>
-          </a:xfrm>
-          <a:prstGeom prst="rect">
-            <a:avLst/>
-          </a:prstGeom>
-          <a:noFill/>
-        </p:spPr>
-        <p:txBody>
-          <a:bodyPr wrap="none">
-            <a:spAutoFit/>
-          </a:bodyPr>
-          <a:lstStyle/>
-          <a:p>
-            <a:r>
-              <a:t>8 Design Patterns EVERY Developer Should Know - 09:03:000</a:t>
-            </a:r>
-          </a:p>
-        </p:txBody>
-      </p:sp>
-    </p:spTree>
-  </p:cSld>
-  <p:clrMapOvr>
-    <a:masterClrMapping/>
-  </p:clrMapOvr>
-</p:sld>
-</file>
-
-<file path=ppt/slides/slide18.xml><?xml version="1.0" encoding="utf-8"?>
-<p:sld xmlns:a="http://schemas.openxmlformats.org/drawingml/2006/main" xmlns:p="http://schemas.openxmlformats.org/presentationml/2006/main" xmlns:r="http://schemas.openxmlformats.org/officeDocument/2006/relationships">
-  <p:cSld>
-    <p:spTree>
-      <p:nvGrpSpPr>
-        <p:cNvPr id="1" name=""/>
-        <p:cNvGrpSpPr/>
-        <p:nvPr/>
-      </p:nvGrpSpPr>
-      <p:grpSpPr/>
-      <p:pic>
-        <p:nvPicPr>
-          <p:cNvPr id="2" name="Picture 1" descr="image.jpg"/>
-          <p:cNvPicPr>
-            <a:picLocks noChangeAspect="1"/>
-          </p:cNvPicPr>
-          <p:nvPr/>
-        </p:nvPicPr>
-        <p:blipFill>
-          <a:blip r:embed="rId2"/>
-          <a:stretch>
-            <a:fillRect/>
-          </a:stretch>
-        </p:blipFill>
-        <p:spPr>
-          <a:xfrm>
-            <a:off x="1523999" y="1371600"/>
-            <a:ext cx="6096000" cy="3429000"/>
-          </a:xfrm>
-          <a:prstGeom prst="rect">
-            <a:avLst/>
-          </a:prstGeom>
-        </p:spPr>
-      </p:pic>
-      <p:sp>
-        <p:nvSpPr>
-          <p:cNvPr id="3" name="TextBox 2"/>
-          <p:cNvSpPr txBox="1"/>
-          <p:nvPr/>
-        </p:nvSpPr>
-        <p:spPr>
-          <a:xfrm>
-            <a:off x="914400" y="5943600"/>
-            <a:ext cx="7315200" cy="914400"/>
-          </a:xfrm>
-          <a:prstGeom prst="rect">
-            <a:avLst/>
-          </a:prstGeom>
-          <a:noFill/>
-        </p:spPr>
-        <p:txBody>
-          <a:bodyPr wrap="none">
-            <a:spAutoFit/>
-          </a:bodyPr>
-          <a:lstStyle/>
-          <a:p>
-            <a:r>
-              <a:t>8 Design Patterns EVERY Developer Should Know - 09:11:000</a:t>
-            </a:r>
-          </a:p>
-        </p:txBody>
-      </p:sp>
-    </p:spTree>
-  </p:cSld>
-  <p:clrMapOvr>
-    <a:masterClrMapping/>
-  </p:clrMapOvr>
-</p:sld>
-</file>
-
-<file path=ppt/slides/slide19.xml><?xml version="1.0" encoding="utf-8"?>
-<p:sld xmlns:a="http://schemas.openxmlformats.org/drawingml/2006/main" xmlns:p="http://schemas.openxmlformats.org/presentationml/2006/main" xmlns:r="http://schemas.openxmlformats.org/officeDocument/2006/relationships">
-  <p:cSld>
-    <p:spTree>
-      <p:nvGrpSpPr>
-        <p:cNvPr id="1" name=""/>
-        <p:cNvGrpSpPr/>
-        <p:nvPr/>
-      </p:nvGrpSpPr>
-      <p:grpSpPr/>
-      <p:pic>
-        <p:nvPicPr>
-          <p:cNvPr id="2" name="Picture 1" descr="image.jpg"/>
-          <p:cNvPicPr>
-            <a:picLocks noChangeAspect="1"/>
-          </p:cNvPicPr>
-          <p:nvPr/>
-        </p:nvPicPr>
-        <p:blipFill>
-          <a:blip r:embed="rId2"/>
-          <a:stretch>
-            <a:fillRect/>
-          </a:stretch>
-        </p:blipFill>
-        <p:spPr>
-          <a:xfrm>
-            <a:off x="1523999" y="1371600"/>
-            <a:ext cx="6096000" cy="3429000"/>
-          </a:xfrm>
-          <a:prstGeom prst="rect">
-            <a:avLst/>
-          </a:prstGeom>
-        </p:spPr>
-      </p:pic>
-      <p:sp>
-        <p:nvSpPr>
-          <p:cNvPr id="3" name="TextBox 2"/>
-          <p:cNvSpPr txBox="1"/>
-          <p:nvPr/>
-        </p:nvSpPr>
-        <p:spPr>
-          <a:xfrm>
-            <a:off x="914400" y="5943600"/>
-            <a:ext cx="7315200" cy="914400"/>
-          </a:xfrm>
-          <a:prstGeom prst="rect">
-            <a:avLst/>
-          </a:prstGeom>
-          <a:noFill/>
-        </p:spPr>
-        <p:txBody>
-          <a:bodyPr wrap="none">
-            <a:spAutoFit/>
-          </a:bodyPr>
-          <a:lstStyle/>
-          <a:p>
-            <a:r>
-              <a:t>8 Design Patterns EVERY Developer Should Know - 09:14:000</a:t>
+              <a:t>8 Design Patterns EVERY Developer Should Know - 09:45:000</a:t>
             </a:r>
           </a:p>
         </p:txBody>
@@ -3906,48 +3250,6 @@
           <p:nvPr/>
         </p:nvPicPr>
         <p:blipFill>
-          <a:blip r:embed="rId3"/>
-          <a:stretch>
-            <a:fillRect/>
-          </a:stretch>
-        </p:blipFill>
-        <p:spPr>
-          <a:xfrm>
-            <a:off x="914400" y="914400"/>
-            <a:ext cx="7315200" cy="5486400"/>
-          </a:xfrm>
-          <a:prstGeom prst="rect">
-            <a:avLst/>
-          </a:prstGeom>
-        </p:spPr>
-      </p:pic>
-    </p:spTree>
-  </p:cSld>
-  <p:clrMapOvr>
-    <a:masterClrMapping/>
-  </p:clrMapOvr>
-</p:sld>
-</file>
-
-<file path=ppt/slides/slide20.xml><?xml version="1.0" encoding="utf-8"?>
-<p:sld xmlns:a="http://schemas.openxmlformats.org/drawingml/2006/main" xmlns:p="http://schemas.openxmlformats.org/presentationml/2006/main" xmlns:r="http://schemas.openxmlformats.org/officeDocument/2006/relationships">
-  <p:cSld>
-    <p:spTree>
-      <p:nvGrpSpPr>
-        <p:cNvPr id="1" name=""/>
-        <p:cNvGrpSpPr/>
-        <p:nvPr/>
-      </p:nvGrpSpPr>
-      <p:grpSpPr/>
-      <p:pic>
-        <p:nvPicPr>
-          <p:cNvPr id="2" name="Picture 1" descr="image.jpg"/>
-          <p:cNvPicPr>
-            <a:picLocks noChangeAspect="1"/>
-          </p:cNvPicPr>
-          <p:nvPr/>
-        </p:nvPicPr>
-        <p:blipFill>
           <a:blip r:embed="rId2"/>
           <a:stretch>
             <a:fillRect/>
@@ -3955,672 +3257,14 @@
         </p:blipFill>
         <p:spPr>
           <a:xfrm>
-            <a:off x="1523999" y="1371600"/>
-            <a:ext cx="6096000" cy="3429000"/>
+            <a:off x="914400" y="914400"/>
+            <a:ext cx="7315200" cy="5486400"/>
           </a:xfrm>
           <a:prstGeom prst="rect">
             <a:avLst/>
           </a:prstGeom>
         </p:spPr>
       </p:pic>
-      <p:sp>
-        <p:nvSpPr>
-          <p:cNvPr id="3" name="TextBox 2"/>
-          <p:cNvSpPr txBox="1"/>
-          <p:nvPr/>
-        </p:nvSpPr>
-        <p:spPr>
-          <a:xfrm>
-            <a:off x="914400" y="5943600"/>
-            <a:ext cx="7315200" cy="914400"/>
-          </a:xfrm>
-          <a:prstGeom prst="rect">
-            <a:avLst/>
-          </a:prstGeom>
-          <a:noFill/>
-        </p:spPr>
-        <p:txBody>
-          <a:bodyPr wrap="none">
-            <a:spAutoFit/>
-          </a:bodyPr>
-          <a:lstStyle/>
-          <a:p>
-            <a:r>
-              <a:t>8 Design Patterns EVERY Developer Should Know - 09:16:000</a:t>
-            </a:r>
-          </a:p>
-        </p:txBody>
-      </p:sp>
-    </p:spTree>
-  </p:cSld>
-  <p:clrMapOvr>
-    <a:masterClrMapping/>
-  </p:clrMapOvr>
-</p:sld>
-</file>
-
-<file path=ppt/slides/slide21.xml><?xml version="1.0" encoding="utf-8"?>
-<p:sld xmlns:a="http://schemas.openxmlformats.org/drawingml/2006/main" xmlns:p="http://schemas.openxmlformats.org/presentationml/2006/main" xmlns:r="http://schemas.openxmlformats.org/officeDocument/2006/relationships">
-  <p:cSld>
-    <p:spTree>
-      <p:nvGrpSpPr>
-        <p:cNvPr id="1" name=""/>
-        <p:cNvGrpSpPr/>
-        <p:nvPr/>
-      </p:nvGrpSpPr>
-      <p:grpSpPr/>
-      <p:pic>
-        <p:nvPicPr>
-          <p:cNvPr id="2" name="Picture 1" descr="image.jpg"/>
-          <p:cNvPicPr>
-            <a:picLocks noChangeAspect="1"/>
-          </p:cNvPicPr>
-          <p:nvPr/>
-        </p:nvPicPr>
-        <p:blipFill>
-          <a:blip r:embed="rId2"/>
-          <a:stretch>
-            <a:fillRect/>
-          </a:stretch>
-        </p:blipFill>
-        <p:spPr>
-          <a:xfrm>
-            <a:off x="1523999" y="1371600"/>
-            <a:ext cx="6096000" cy="3429000"/>
-          </a:xfrm>
-          <a:prstGeom prst="rect">
-            <a:avLst/>
-          </a:prstGeom>
-        </p:spPr>
-      </p:pic>
-      <p:sp>
-        <p:nvSpPr>
-          <p:cNvPr id="3" name="TextBox 2"/>
-          <p:cNvSpPr txBox="1"/>
-          <p:nvPr/>
-        </p:nvSpPr>
-        <p:spPr>
-          <a:xfrm>
-            <a:off x="914400" y="5943600"/>
-            <a:ext cx="7315200" cy="914400"/>
-          </a:xfrm>
-          <a:prstGeom prst="rect">
-            <a:avLst/>
-          </a:prstGeom>
-          <a:noFill/>
-        </p:spPr>
-        <p:txBody>
-          <a:bodyPr wrap="none">
-            <a:spAutoFit/>
-          </a:bodyPr>
-          <a:lstStyle/>
-          <a:p>
-            <a:r>
-              <a:t>8 Design Patterns EVERY Developer Should Know - 09:18:000</a:t>
-            </a:r>
-          </a:p>
-        </p:txBody>
-      </p:sp>
-    </p:spTree>
-  </p:cSld>
-  <p:clrMapOvr>
-    <a:masterClrMapping/>
-  </p:clrMapOvr>
-</p:sld>
-</file>
-
-<file path=ppt/slides/slide22.xml><?xml version="1.0" encoding="utf-8"?>
-<p:sld xmlns:a="http://schemas.openxmlformats.org/drawingml/2006/main" xmlns:p="http://schemas.openxmlformats.org/presentationml/2006/main" xmlns:r="http://schemas.openxmlformats.org/officeDocument/2006/relationships">
-  <p:cSld>
-    <p:spTree>
-      <p:nvGrpSpPr>
-        <p:cNvPr id="1" name=""/>
-        <p:cNvGrpSpPr/>
-        <p:nvPr/>
-      </p:nvGrpSpPr>
-      <p:grpSpPr/>
-      <p:pic>
-        <p:nvPicPr>
-          <p:cNvPr id="2" name="Picture 1" descr="image.jpg"/>
-          <p:cNvPicPr>
-            <a:picLocks noChangeAspect="1"/>
-          </p:cNvPicPr>
-          <p:nvPr/>
-        </p:nvPicPr>
-        <p:blipFill>
-          <a:blip r:embed="rId2"/>
-          <a:stretch>
-            <a:fillRect/>
-          </a:stretch>
-        </p:blipFill>
-        <p:spPr>
-          <a:xfrm>
-            <a:off x="1523999" y="1371600"/>
-            <a:ext cx="6096000" cy="3429000"/>
-          </a:xfrm>
-          <a:prstGeom prst="rect">
-            <a:avLst/>
-          </a:prstGeom>
-        </p:spPr>
-      </p:pic>
-      <p:sp>
-        <p:nvSpPr>
-          <p:cNvPr id="3" name="TextBox 2"/>
-          <p:cNvSpPr txBox="1"/>
-          <p:nvPr/>
-        </p:nvSpPr>
-        <p:spPr>
-          <a:xfrm>
-            <a:off x="914400" y="5943600"/>
-            <a:ext cx="7315200" cy="914400"/>
-          </a:xfrm>
-          <a:prstGeom prst="rect">
-            <a:avLst/>
-          </a:prstGeom>
-          <a:noFill/>
-        </p:spPr>
-        <p:txBody>
-          <a:bodyPr wrap="none">
-            <a:spAutoFit/>
-          </a:bodyPr>
-          <a:lstStyle/>
-          <a:p>
-            <a:r>
-              <a:t>8 Design Patterns EVERY Developer Should Know - 09:24:000</a:t>
-            </a:r>
-          </a:p>
-        </p:txBody>
-      </p:sp>
-    </p:spTree>
-  </p:cSld>
-  <p:clrMapOvr>
-    <a:masterClrMapping/>
-  </p:clrMapOvr>
-</p:sld>
-</file>
-
-<file path=ppt/slides/slide23.xml><?xml version="1.0" encoding="utf-8"?>
-<p:sld xmlns:a="http://schemas.openxmlformats.org/drawingml/2006/main" xmlns:p="http://schemas.openxmlformats.org/presentationml/2006/main" xmlns:r="http://schemas.openxmlformats.org/officeDocument/2006/relationships">
-  <p:cSld>
-    <p:spTree>
-      <p:nvGrpSpPr>
-        <p:cNvPr id="1" name=""/>
-        <p:cNvGrpSpPr/>
-        <p:nvPr/>
-      </p:nvGrpSpPr>
-      <p:grpSpPr/>
-      <p:pic>
-        <p:nvPicPr>
-          <p:cNvPr id="2" name="Picture 1" descr="image.jpg"/>
-          <p:cNvPicPr>
-            <a:picLocks noChangeAspect="1"/>
-          </p:cNvPicPr>
-          <p:nvPr/>
-        </p:nvPicPr>
-        <p:blipFill>
-          <a:blip r:embed="rId2"/>
-          <a:stretch>
-            <a:fillRect/>
-          </a:stretch>
-        </p:blipFill>
-        <p:spPr>
-          <a:xfrm>
-            <a:off x="1523999" y="1371600"/>
-            <a:ext cx="6096000" cy="3429000"/>
-          </a:xfrm>
-          <a:prstGeom prst="rect">
-            <a:avLst/>
-          </a:prstGeom>
-        </p:spPr>
-      </p:pic>
-      <p:sp>
-        <p:nvSpPr>
-          <p:cNvPr id="3" name="TextBox 2"/>
-          <p:cNvSpPr txBox="1"/>
-          <p:nvPr/>
-        </p:nvSpPr>
-        <p:spPr>
-          <a:xfrm>
-            <a:off x="914400" y="5943600"/>
-            <a:ext cx="7315200" cy="914400"/>
-          </a:xfrm>
-          <a:prstGeom prst="rect">
-            <a:avLst/>
-          </a:prstGeom>
-          <a:noFill/>
-        </p:spPr>
-        <p:txBody>
-          <a:bodyPr wrap="none">
-            <a:spAutoFit/>
-          </a:bodyPr>
-          <a:lstStyle/>
-          <a:p>
-            <a:r>
-              <a:t>8 Design Patterns EVERY Developer Should Know - 09:26:000</a:t>
-            </a:r>
-          </a:p>
-        </p:txBody>
-      </p:sp>
-    </p:spTree>
-  </p:cSld>
-  <p:clrMapOvr>
-    <a:masterClrMapping/>
-  </p:clrMapOvr>
-</p:sld>
-</file>
-
-<file path=ppt/slides/slide24.xml><?xml version="1.0" encoding="utf-8"?>
-<p:sld xmlns:a="http://schemas.openxmlformats.org/drawingml/2006/main" xmlns:p="http://schemas.openxmlformats.org/presentationml/2006/main" xmlns:r="http://schemas.openxmlformats.org/officeDocument/2006/relationships">
-  <p:cSld>
-    <p:spTree>
-      <p:nvGrpSpPr>
-        <p:cNvPr id="1" name=""/>
-        <p:cNvGrpSpPr/>
-        <p:nvPr/>
-      </p:nvGrpSpPr>
-      <p:grpSpPr/>
-      <p:pic>
-        <p:nvPicPr>
-          <p:cNvPr id="2" name="Picture 1" descr="image.jpg"/>
-          <p:cNvPicPr>
-            <a:picLocks noChangeAspect="1"/>
-          </p:cNvPicPr>
-          <p:nvPr/>
-        </p:nvPicPr>
-        <p:blipFill>
-          <a:blip r:embed="rId2"/>
-          <a:stretch>
-            <a:fillRect/>
-          </a:stretch>
-        </p:blipFill>
-        <p:spPr>
-          <a:xfrm>
-            <a:off x="1523999" y="1371600"/>
-            <a:ext cx="6096000" cy="3429000"/>
-          </a:xfrm>
-          <a:prstGeom prst="rect">
-            <a:avLst/>
-          </a:prstGeom>
-        </p:spPr>
-      </p:pic>
-      <p:sp>
-        <p:nvSpPr>
-          <p:cNvPr id="3" name="TextBox 2"/>
-          <p:cNvSpPr txBox="1"/>
-          <p:nvPr/>
-        </p:nvSpPr>
-        <p:spPr>
-          <a:xfrm>
-            <a:off x="914400" y="5943600"/>
-            <a:ext cx="7315200" cy="914400"/>
-          </a:xfrm>
-          <a:prstGeom prst="rect">
-            <a:avLst/>
-          </a:prstGeom>
-          <a:noFill/>
-        </p:spPr>
-        <p:txBody>
-          <a:bodyPr wrap="none">
-            <a:spAutoFit/>
-          </a:bodyPr>
-          <a:lstStyle/>
-          <a:p>
-            <a:r>
-              <a:t>8 Design Patterns EVERY Developer Should Know - 09:27:000</a:t>
-            </a:r>
-          </a:p>
-        </p:txBody>
-      </p:sp>
-    </p:spTree>
-  </p:cSld>
-  <p:clrMapOvr>
-    <a:masterClrMapping/>
-  </p:clrMapOvr>
-</p:sld>
-</file>
-
-<file path=ppt/slides/slide25.xml><?xml version="1.0" encoding="utf-8"?>
-<p:sld xmlns:a="http://schemas.openxmlformats.org/drawingml/2006/main" xmlns:p="http://schemas.openxmlformats.org/presentationml/2006/main" xmlns:r="http://schemas.openxmlformats.org/officeDocument/2006/relationships">
-  <p:cSld>
-    <p:spTree>
-      <p:nvGrpSpPr>
-        <p:cNvPr id="1" name=""/>
-        <p:cNvGrpSpPr/>
-        <p:nvPr/>
-      </p:nvGrpSpPr>
-      <p:grpSpPr/>
-      <p:pic>
-        <p:nvPicPr>
-          <p:cNvPr id="2" name="Picture 1" descr="image.jpg"/>
-          <p:cNvPicPr>
-            <a:picLocks noChangeAspect="1"/>
-          </p:cNvPicPr>
-          <p:nvPr/>
-        </p:nvPicPr>
-        <p:blipFill>
-          <a:blip r:embed="rId2"/>
-          <a:stretch>
-            <a:fillRect/>
-          </a:stretch>
-        </p:blipFill>
-        <p:spPr>
-          <a:xfrm>
-            <a:off x="1523999" y="1371600"/>
-            <a:ext cx="6096000" cy="3429000"/>
-          </a:xfrm>
-          <a:prstGeom prst="rect">
-            <a:avLst/>
-          </a:prstGeom>
-        </p:spPr>
-      </p:pic>
-      <p:sp>
-        <p:nvSpPr>
-          <p:cNvPr id="3" name="TextBox 2"/>
-          <p:cNvSpPr txBox="1"/>
-          <p:nvPr/>
-        </p:nvSpPr>
-        <p:spPr>
-          <a:xfrm>
-            <a:off x="914400" y="5943600"/>
-            <a:ext cx="7315200" cy="914400"/>
-          </a:xfrm>
-          <a:prstGeom prst="rect">
-            <a:avLst/>
-          </a:prstGeom>
-          <a:noFill/>
-        </p:spPr>
-        <p:txBody>
-          <a:bodyPr wrap="none">
-            <a:spAutoFit/>
-          </a:bodyPr>
-          <a:lstStyle/>
-          <a:p>
-            <a:r>
-              <a:t>8 Design Patterns EVERY Developer Should Know - 09:28:000</a:t>
-            </a:r>
-          </a:p>
-        </p:txBody>
-      </p:sp>
-    </p:spTree>
-  </p:cSld>
-  <p:clrMapOvr>
-    <a:masterClrMapping/>
-  </p:clrMapOvr>
-</p:sld>
-</file>
-
-<file path=ppt/slides/slide26.xml><?xml version="1.0" encoding="utf-8"?>
-<p:sld xmlns:a="http://schemas.openxmlformats.org/drawingml/2006/main" xmlns:p="http://schemas.openxmlformats.org/presentationml/2006/main" xmlns:r="http://schemas.openxmlformats.org/officeDocument/2006/relationships">
-  <p:cSld>
-    <p:spTree>
-      <p:nvGrpSpPr>
-        <p:cNvPr id="1" name=""/>
-        <p:cNvGrpSpPr/>
-        <p:nvPr/>
-      </p:nvGrpSpPr>
-      <p:grpSpPr/>
-      <p:pic>
-        <p:nvPicPr>
-          <p:cNvPr id="2" name="Picture 1" descr="image.jpg"/>
-          <p:cNvPicPr>
-            <a:picLocks noChangeAspect="1"/>
-          </p:cNvPicPr>
-          <p:nvPr/>
-        </p:nvPicPr>
-        <p:blipFill>
-          <a:blip r:embed="rId2"/>
-          <a:stretch>
-            <a:fillRect/>
-          </a:stretch>
-        </p:blipFill>
-        <p:spPr>
-          <a:xfrm>
-            <a:off x="1523999" y="1371600"/>
-            <a:ext cx="6096000" cy="3429000"/>
-          </a:xfrm>
-          <a:prstGeom prst="rect">
-            <a:avLst/>
-          </a:prstGeom>
-        </p:spPr>
-      </p:pic>
-      <p:sp>
-        <p:nvSpPr>
-          <p:cNvPr id="3" name="TextBox 2"/>
-          <p:cNvSpPr txBox="1"/>
-          <p:nvPr/>
-        </p:nvSpPr>
-        <p:spPr>
-          <a:xfrm>
-            <a:off x="914400" y="5943600"/>
-            <a:ext cx="7315200" cy="914400"/>
-          </a:xfrm>
-          <a:prstGeom prst="rect">
-            <a:avLst/>
-          </a:prstGeom>
-          <a:noFill/>
-        </p:spPr>
-        <p:txBody>
-          <a:bodyPr wrap="none">
-            <a:spAutoFit/>
-          </a:bodyPr>
-          <a:lstStyle/>
-          <a:p>
-            <a:r>
-              <a:t>8 Design Patterns EVERY Developer Should Know - 09:29:000</a:t>
-            </a:r>
-          </a:p>
-        </p:txBody>
-      </p:sp>
-    </p:spTree>
-  </p:cSld>
-  <p:clrMapOvr>
-    <a:masterClrMapping/>
-  </p:clrMapOvr>
-</p:sld>
-</file>
-
-<file path=ppt/slides/slide27.xml><?xml version="1.0" encoding="utf-8"?>
-<p:sld xmlns:a="http://schemas.openxmlformats.org/drawingml/2006/main" xmlns:p="http://schemas.openxmlformats.org/presentationml/2006/main" xmlns:r="http://schemas.openxmlformats.org/officeDocument/2006/relationships">
-  <p:cSld>
-    <p:spTree>
-      <p:nvGrpSpPr>
-        <p:cNvPr id="1" name=""/>
-        <p:cNvGrpSpPr/>
-        <p:nvPr/>
-      </p:nvGrpSpPr>
-      <p:grpSpPr/>
-      <p:pic>
-        <p:nvPicPr>
-          <p:cNvPr id="2" name="Picture 1" descr="image.jpg"/>
-          <p:cNvPicPr>
-            <a:picLocks noChangeAspect="1"/>
-          </p:cNvPicPr>
-          <p:nvPr/>
-        </p:nvPicPr>
-        <p:blipFill>
-          <a:blip r:embed="rId2"/>
-          <a:stretch>
-            <a:fillRect/>
-          </a:stretch>
-        </p:blipFill>
-        <p:spPr>
-          <a:xfrm>
-            <a:off x="1523999" y="1371600"/>
-            <a:ext cx="6096000" cy="3429000"/>
-          </a:xfrm>
-          <a:prstGeom prst="rect">
-            <a:avLst/>
-          </a:prstGeom>
-        </p:spPr>
-      </p:pic>
-      <p:sp>
-        <p:nvSpPr>
-          <p:cNvPr id="3" name="TextBox 2"/>
-          <p:cNvSpPr txBox="1"/>
-          <p:nvPr/>
-        </p:nvSpPr>
-        <p:spPr>
-          <a:xfrm>
-            <a:off x="914400" y="5943600"/>
-            <a:ext cx="7315200" cy="914400"/>
-          </a:xfrm>
-          <a:prstGeom prst="rect">
-            <a:avLst/>
-          </a:prstGeom>
-          <a:noFill/>
-        </p:spPr>
-        <p:txBody>
-          <a:bodyPr wrap="none">
-            <a:spAutoFit/>
-          </a:bodyPr>
-          <a:lstStyle/>
-          <a:p>
-            <a:r>
-              <a:t>8 Design Patterns EVERY Developer Should Know - 09:30:000</a:t>
-            </a:r>
-          </a:p>
-        </p:txBody>
-      </p:sp>
-    </p:spTree>
-  </p:cSld>
-  <p:clrMapOvr>
-    <a:masterClrMapping/>
-  </p:clrMapOvr>
-</p:sld>
-</file>
-
-<file path=ppt/slides/slide28.xml><?xml version="1.0" encoding="utf-8"?>
-<p:sld xmlns:a="http://schemas.openxmlformats.org/drawingml/2006/main" xmlns:p="http://schemas.openxmlformats.org/presentationml/2006/main" xmlns:r="http://schemas.openxmlformats.org/officeDocument/2006/relationships">
-  <p:cSld>
-    <p:spTree>
-      <p:nvGrpSpPr>
-        <p:cNvPr id="1" name=""/>
-        <p:cNvGrpSpPr/>
-        <p:nvPr/>
-      </p:nvGrpSpPr>
-      <p:grpSpPr/>
-      <p:pic>
-        <p:nvPicPr>
-          <p:cNvPr id="2" name="Picture 1" descr="image.jpg"/>
-          <p:cNvPicPr>
-            <a:picLocks noChangeAspect="1"/>
-          </p:cNvPicPr>
-          <p:nvPr/>
-        </p:nvPicPr>
-        <p:blipFill>
-          <a:blip r:embed="rId2"/>
-          <a:stretch>
-            <a:fillRect/>
-          </a:stretch>
-        </p:blipFill>
-        <p:spPr>
-          <a:xfrm>
-            <a:off x="1523999" y="1371600"/>
-            <a:ext cx="6096000" cy="3429000"/>
-          </a:xfrm>
-          <a:prstGeom prst="rect">
-            <a:avLst/>
-          </a:prstGeom>
-        </p:spPr>
-      </p:pic>
-      <p:sp>
-        <p:nvSpPr>
-          <p:cNvPr id="3" name="TextBox 2"/>
-          <p:cNvSpPr txBox="1"/>
-          <p:nvPr/>
-        </p:nvSpPr>
-        <p:spPr>
-          <a:xfrm>
-            <a:off x="914400" y="5943600"/>
-            <a:ext cx="7315200" cy="914400"/>
-          </a:xfrm>
-          <a:prstGeom prst="rect">
-            <a:avLst/>
-          </a:prstGeom>
-          <a:noFill/>
-        </p:spPr>
-        <p:txBody>
-          <a:bodyPr wrap="none">
-            <a:spAutoFit/>
-          </a:bodyPr>
-          <a:lstStyle/>
-          <a:p>
-            <a:r>
-              <a:t>8 Design Patterns EVERY Developer Should Know - 09:33:000</a:t>
-            </a:r>
-          </a:p>
-        </p:txBody>
-      </p:sp>
-    </p:spTree>
-  </p:cSld>
-  <p:clrMapOvr>
-    <a:masterClrMapping/>
-  </p:clrMapOvr>
-</p:sld>
-</file>
-
-<file path=ppt/slides/slide29.xml><?xml version="1.0" encoding="utf-8"?>
-<p:sld xmlns:a="http://schemas.openxmlformats.org/drawingml/2006/main" xmlns:p="http://schemas.openxmlformats.org/presentationml/2006/main" xmlns:r="http://schemas.openxmlformats.org/officeDocument/2006/relationships">
-  <p:cSld>
-    <p:spTree>
-      <p:nvGrpSpPr>
-        <p:cNvPr id="1" name=""/>
-        <p:cNvGrpSpPr/>
-        <p:nvPr/>
-      </p:nvGrpSpPr>
-      <p:grpSpPr/>
-      <p:pic>
-        <p:nvPicPr>
-          <p:cNvPr id="2" name="Picture 1" descr="image.jpg"/>
-          <p:cNvPicPr>
-            <a:picLocks noChangeAspect="1"/>
-          </p:cNvPicPr>
-          <p:nvPr/>
-        </p:nvPicPr>
-        <p:blipFill>
-          <a:blip r:embed="rId2"/>
-          <a:stretch>
-            <a:fillRect/>
-          </a:stretch>
-        </p:blipFill>
-        <p:spPr>
-          <a:xfrm>
-            <a:off x="1523999" y="1371600"/>
-            <a:ext cx="6096000" cy="3429000"/>
-          </a:xfrm>
-          <a:prstGeom prst="rect">
-            <a:avLst/>
-          </a:prstGeom>
-        </p:spPr>
-      </p:pic>
-      <p:sp>
-        <p:nvSpPr>
-          <p:cNvPr id="3" name="TextBox 2"/>
-          <p:cNvSpPr txBox="1"/>
-          <p:nvPr/>
-        </p:nvSpPr>
-        <p:spPr>
-          <a:xfrm>
-            <a:off x="914400" y="5943600"/>
-            <a:ext cx="7315200" cy="914400"/>
-          </a:xfrm>
-          <a:prstGeom prst="rect">
-            <a:avLst/>
-          </a:prstGeom>
-          <a:noFill/>
-        </p:spPr>
-        <p:txBody>
-          <a:bodyPr wrap="none">
-            <a:spAutoFit/>
-          </a:bodyPr>
-          <a:lstStyle/>
-          <a:p>
-            <a:r>
-              <a:t>8 Design Patterns EVERY Developer Should Know - 09:36:000</a:t>
-            </a:r>
-          </a:p>
-        </p:txBody>
-      </p:sp>
     </p:spTree>
   </p:cSld>
   <p:clrMapOvr>
@@ -4686,497 +3330,7 @@
           <a:lstStyle/>
           <a:p>
             <a:r>
-              <a:t>8 Design Patterns EVERY Developer Should Know - 07:48:000</a:t>
-            </a:r>
-          </a:p>
-        </p:txBody>
-      </p:sp>
-    </p:spTree>
-  </p:cSld>
-  <p:clrMapOvr>
-    <a:masterClrMapping/>
-  </p:clrMapOvr>
-</p:sld>
-</file>
-
-<file path=ppt/slides/slide30.xml><?xml version="1.0" encoding="utf-8"?>
-<p:sld xmlns:a="http://schemas.openxmlformats.org/drawingml/2006/main" xmlns:p="http://schemas.openxmlformats.org/presentationml/2006/main" xmlns:r="http://schemas.openxmlformats.org/officeDocument/2006/relationships">
-  <p:cSld>
-    <p:spTree>
-      <p:nvGrpSpPr>
-        <p:cNvPr id="1" name=""/>
-        <p:cNvGrpSpPr/>
-        <p:nvPr/>
-      </p:nvGrpSpPr>
-      <p:grpSpPr/>
-      <p:pic>
-        <p:nvPicPr>
-          <p:cNvPr id="2" name="Picture 1" descr="image.jpg"/>
-          <p:cNvPicPr>
-            <a:picLocks noChangeAspect="1"/>
-          </p:cNvPicPr>
-          <p:nvPr/>
-        </p:nvPicPr>
-        <p:blipFill>
-          <a:blip r:embed="rId2"/>
-          <a:stretch>
-            <a:fillRect/>
-          </a:stretch>
-        </p:blipFill>
-        <p:spPr>
-          <a:xfrm>
-            <a:off x="1523999" y="1371600"/>
-            <a:ext cx="6096000" cy="3429000"/>
-          </a:xfrm>
-          <a:prstGeom prst="rect">
-            <a:avLst/>
-          </a:prstGeom>
-        </p:spPr>
-      </p:pic>
-      <p:sp>
-        <p:nvSpPr>
-          <p:cNvPr id="3" name="TextBox 2"/>
-          <p:cNvSpPr txBox="1"/>
-          <p:nvPr/>
-        </p:nvSpPr>
-        <p:spPr>
-          <a:xfrm>
-            <a:off x="914400" y="5943600"/>
-            <a:ext cx="7315200" cy="914400"/>
-          </a:xfrm>
-          <a:prstGeom prst="rect">
-            <a:avLst/>
-          </a:prstGeom>
-          <a:noFill/>
-        </p:spPr>
-        <p:txBody>
-          <a:bodyPr wrap="none">
-            <a:spAutoFit/>
-          </a:bodyPr>
-          <a:lstStyle/>
-          <a:p>
-            <a:r>
-              <a:t>8 Design Patterns EVERY Developer Should Know - 09:38:000</a:t>
-            </a:r>
-          </a:p>
-        </p:txBody>
-      </p:sp>
-    </p:spTree>
-  </p:cSld>
-  <p:clrMapOvr>
-    <a:masterClrMapping/>
-  </p:clrMapOvr>
-</p:sld>
-</file>
-
-<file path=ppt/slides/slide31.xml><?xml version="1.0" encoding="utf-8"?>
-<p:sld xmlns:a="http://schemas.openxmlformats.org/drawingml/2006/main" xmlns:p="http://schemas.openxmlformats.org/presentationml/2006/main" xmlns:r="http://schemas.openxmlformats.org/officeDocument/2006/relationships">
-  <p:cSld>
-    <p:spTree>
-      <p:nvGrpSpPr>
-        <p:cNvPr id="1" name=""/>
-        <p:cNvGrpSpPr/>
-        <p:nvPr/>
-      </p:nvGrpSpPr>
-      <p:grpSpPr/>
-      <p:pic>
-        <p:nvPicPr>
-          <p:cNvPr id="2" name="Picture 1" descr="image.jpg"/>
-          <p:cNvPicPr>
-            <a:picLocks noChangeAspect="1"/>
-          </p:cNvPicPr>
-          <p:nvPr/>
-        </p:nvPicPr>
-        <p:blipFill>
-          <a:blip r:embed="rId2"/>
-          <a:stretch>
-            <a:fillRect/>
-          </a:stretch>
-        </p:blipFill>
-        <p:spPr>
-          <a:xfrm>
-            <a:off x="1523999" y="1371600"/>
-            <a:ext cx="6096000" cy="3429000"/>
-          </a:xfrm>
-          <a:prstGeom prst="rect">
-            <a:avLst/>
-          </a:prstGeom>
-        </p:spPr>
-      </p:pic>
-      <p:sp>
-        <p:nvSpPr>
-          <p:cNvPr id="3" name="TextBox 2"/>
-          <p:cNvSpPr txBox="1"/>
-          <p:nvPr/>
-        </p:nvSpPr>
-        <p:spPr>
-          <a:xfrm>
-            <a:off x="914400" y="5943600"/>
-            <a:ext cx="7315200" cy="914400"/>
-          </a:xfrm>
-          <a:prstGeom prst="rect">
-            <a:avLst/>
-          </a:prstGeom>
-          <a:noFill/>
-        </p:spPr>
-        <p:txBody>
-          <a:bodyPr wrap="none">
-            <a:spAutoFit/>
-          </a:bodyPr>
-          <a:lstStyle/>
-          <a:p>
-            <a:r>
-              <a:t>8 Design Patterns EVERY Developer Should Know - 09:39:000</a:t>
-            </a:r>
-          </a:p>
-        </p:txBody>
-      </p:sp>
-    </p:spTree>
-  </p:cSld>
-  <p:clrMapOvr>
-    <a:masterClrMapping/>
-  </p:clrMapOvr>
-</p:sld>
-</file>
-
-<file path=ppt/slides/slide32.xml><?xml version="1.0" encoding="utf-8"?>
-<p:sld xmlns:a="http://schemas.openxmlformats.org/drawingml/2006/main" xmlns:p="http://schemas.openxmlformats.org/presentationml/2006/main" xmlns:r="http://schemas.openxmlformats.org/officeDocument/2006/relationships">
-  <p:cSld>
-    <p:spTree>
-      <p:nvGrpSpPr>
-        <p:cNvPr id="1" name=""/>
-        <p:cNvGrpSpPr/>
-        <p:nvPr/>
-      </p:nvGrpSpPr>
-      <p:grpSpPr/>
-      <p:pic>
-        <p:nvPicPr>
-          <p:cNvPr id="2" name="Picture 1" descr="image.jpg"/>
-          <p:cNvPicPr>
-            <a:picLocks noChangeAspect="1"/>
-          </p:cNvPicPr>
-          <p:nvPr/>
-        </p:nvPicPr>
-        <p:blipFill>
-          <a:blip r:embed="rId2"/>
-          <a:stretch>
-            <a:fillRect/>
-          </a:stretch>
-        </p:blipFill>
-        <p:spPr>
-          <a:xfrm>
-            <a:off x="1523999" y="1371600"/>
-            <a:ext cx="6096000" cy="3429000"/>
-          </a:xfrm>
-          <a:prstGeom prst="rect">
-            <a:avLst/>
-          </a:prstGeom>
-        </p:spPr>
-      </p:pic>
-      <p:sp>
-        <p:nvSpPr>
-          <p:cNvPr id="3" name="TextBox 2"/>
-          <p:cNvSpPr txBox="1"/>
-          <p:nvPr/>
-        </p:nvSpPr>
-        <p:spPr>
-          <a:xfrm>
-            <a:off x="914400" y="5943600"/>
-            <a:ext cx="7315200" cy="914400"/>
-          </a:xfrm>
-          <a:prstGeom prst="rect">
-            <a:avLst/>
-          </a:prstGeom>
-          <a:noFill/>
-        </p:spPr>
-        <p:txBody>
-          <a:bodyPr wrap="none">
-            <a:spAutoFit/>
-          </a:bodyPr>
-          <a:lstStyle/>
-          <a:p>
-            <a:r>
-              <a:t>8 Design Patterns EVERY Developer Should Know - 09:40:000</a:t>
-            </a:r>
-          </a:p>
-        </p:txBody>
-      </p:sp>
-    </p:spTree>
-  </p:cSld>
-  <p:clrMapOvr>
-    <a:masterClrMapping/>
-  </p:clrMapOvr>
-</p:sld>
-</file>
-
-<file path=ppt/slides/slide33.xml><?xml version="1.0" encoding="utf-8"?>
-<p:sld xmlns:a="http://schemas.openxmlformats.org/drawingml/2006/main" xmlns:p="http://schemas.openxmlformats.org/presentationml/2006/main" xmlns:r="http://schemas.openxmlformats.org/officeDocument/2006/relationships">
-  <p:cSld>
-    <p:spTree>
-      <p:nvGrpSpPr>
-        <p:cNvPr id="1" name=""/>
-        <p:cNvGrpSpPr/>
-        <p:nvPr/>
-      </p:nvGrpSpPr>
-      <p:grpSpPr/>
-      <p:pic>
-        <p:nvPicPr>
-          <p:cNvPr id="2" name="Picture 1" descr="image.jpg"/>
-          <p:cNvPicPr>
-            <a:picLocks noChangeAspect="1"/>
-          </p:cNvPicPr>
-          <p:nvPr/>
-        </p:nvPicPr>
-        <p:blipFill>
-          <a:blip r:embed="rId2"/>
-          <a:stretch>
-            <a:fillRect/>
-          </a:stretch>
-        </p:blipFill>
-        <p:spPr>
-          <a:xfrm>
-            <a:off x="1523999" y="1371600"/>
-            <a:ext cx="6096000" cy="3429000"/>
-          </a:xfrm>
-          <a:prstGeom prst="rect">
-            <a:avLst/>
-          </a:prstGeom>
-        </p:spPr>
-      </p:pic>
-      <p:sp>
-        <p:nvSpPr>
-          <p:cNvPr id="3" name="TextBox 2"/>
-          <p:cNvSpPr txBox="1"/>
-          <p:nvPr/>
-        </p:nvSpPr>
-        <p:spPr>
-          <a:xfrm>
-            <a:off x="914400" y="5943600"/>
-            <a:ext cx="7315200" cy="914400"/>
-          </a:xfrm>
-          <a:prstGeom prst="rect">
-            <a:avLst/>
-          </a:prstGeom>
-          <a:noFill/>
-        </p:spPr>
-        <p:txBody>
-          <a:bodyPr wrap="none">
-            <a:spAutoFit/>
-          </a:bodyPr>
-          <a:lstStyle/>
-          <a:p>
-            <a:r>
-              <a:t>8 Design Patterns EVERY Developer Should Know - 09:41:000</a:t>
-            </a:r>
-          </a:p>
-        </p:txBody>
-      </p:sp>
-    </p:spTree>
-  </p:cSld>
-  <p:clrMapOvr>
-    <a:masterClrMapping/>
-  </p:clrMapOvr>
-</p:sld>
-</file>
-
-<file path=ppt/slides/slide34.xml><?xml version="1.0" encoding="utf-8"?>
-<p:sld xmlns:a="http://schemas.openxmlformats.org/drawingml/2006/main" xmlns:p="http://schemas.openxmlformats.org/presentationml/2006/main" xmlns:r="http://schemas.openxmlformats.org/officeDocument/2006/relationships">
-  <p:cSld>
-    <p:spTree>
-      <p:nvGrpSpPr>
-        <p:cNvPr id="1" name=""/>
-        <p:cNvGrpSpPr/>
-        <p:nvPr/>
-      </p:nvGrpSpPr>
-      <p:grpSpPr/>
-      <p:pic>
-        <p:nvPicPr>
-          <p:cNvPr id="2" name="Picture 1" descr="image.jpg"/>
-          <p:cNvPicPr>
-            <a:picLocks noChangeAspect="1"/>
-          </p:cNvPicPr>
-          <p:nvPr/>
-        </p:nvPicPr>
-        <p:blipFill>
-          <a:blip r:embed="rId2"/>
-          <a:stretch>
-            <a:fillRect/>
-          </a:stretch>
-        </p:blipFill>
-        <p:spPr>
-          <a:xfrm>
-            <a:off x="1523999" y="1371600"/>
-            <a:ext cx="6096000" cy="3429000"/>
-          </a:xfrm>
-          <a:prstGeom prst="rect">
-            <a:avLst/>
-          </a:prstGeom>
-        </p:spPr>
-      </p:pic>
-      <p:sp>
-        <p:nvSpPr>
-          <p:cNvPr id="3" name="TextBox 2"/>
-          <p:cNvSpPr txBox="1"/>
-          <p:nvPr/>
-        </p:nvSpPr>
-        <p:spPr>
-          <a:xfrm>
-            <a:off x="914400" y="5943600"/>
-            <a:ext cx="7315200" cy="914400"/>
-          </a:xfrm>
-          <a:prstGeom prst="rect">
-            <a:avLst/>
-          </a:prstGeom>
-          <a:noFill/>
-        </p:spPr>
-        <p:txBody>
-          <a:bodyPr wrap="none">
-            <a:spAutoFit/>
-          </a:bodyPr>
-          <a:lstStyle/>
-          <a:p>
-            <a:r>
-              <a:t>8 Design Patterns EVERY Developer Should Know - 09:43:000</a:t>
-            </a:r>
-          </a:p>
-        </p:txBody>
-      </p:sp>
-    </p:spTree>
-  </p:cSld>
-  <p:clrMapOvr>
-    <a:masterClrMapping/>
-  </p:clrMapOvr>
-</p:sld>
-</file>
-
-<file path=ppt/slides/slide35.xml><?xml version="1.0" encoding="utf-8"?>
-<p:sld xmlns:a="http://schemas.openxmlformats.org/drawingml/2006/main" xmlns:p="http://schemas.openxmlformats.org/presentationml/2006/main" xmlns:r="http://schemas.openxmlformats.org/officeDocument/2006/relationships">
-  <p:cSld>
-    <p:spTree>
-      <p:nvGrpSpPr>
-        <p:cNvPr id="1" name=""/>
-        <p:cNvGrpSpPr/>
-        <p:nvPr/>
-      </p:nvGrpSpPr>
-      <p:grpSpPr/>
-      <p:pic>
-        <p:nvPicPr>
-          <p:cNvPr id="2" name="Picture 1" descr="image.jpg"/>
-          <p:cNvPicPr>
-            <a:picLocks noChangeAspect="1"/>
-          </p:cNvPicPr>
-          <p:nvPr/>
-        </p:nvPicPr>
-        <p:blipFill>
-          <a:blip r:embed="rId2"/>
-          <a:stretch>
-            <a:fillRect/>
-          </a:stretch>
-        </p:blipFill>
-        <p:spPr>
-          <a:xfrm>
-            <a:off x="1523999" y="1371600"/>
-            <a:ext cx="6096000" cy="3429000"/>
-          </a:xfrm>
-          <a:prstGeom prst="rect">
-            <a:avLst/>
-          </a:prstGeom>
-        </p:spPr>
-      </p:pic>
-      <p:sp>
-        <p:nvSpPr>
-          <p:cNvPr id="3" name="TextBox 2"/>
-          <p:cNvSpPr txBox="1"/>
-          <p:nvPr/>
-        </p:nvSpPr>
-        <p:spPr>
-          <a:xfrm>
-            <a:off x="914400" y="5943600"/>
-            <a:ext cx="7315200" cy="914400"/>
-          </a:xfrm>
-          <a:prstGeom prst="rect">
-            <a:avLst/>
-          </a:prstGeom>
-          <a:noFill/>
-        </p:spPr>
-        <p:txBody>
-          <a:bodyPr wrap="none">
-            <a:spAutoFit/>
-          </a:bodyPr>
-          <a:lstStyle/>
-          <a:p>
-            <a:r>
-              <a:t>8 Design Patterns EVERY Developer Should Know - 09:44:000</a:t>
-            </a:r>
-          </a:p>
-        </p:txBody>
-      </p:sp>
-    </p:spTree>
-  </p:cSld>
-  <p:clrMapOvr>
-    <a:masterClrMapping/>
-  </p:clrMapOvr>
-</p:sld>
-</file>
-
-<file path=ppt/slides/slide36.xml><?xml version="1.0" encoding="utf-8"?>
-<p:sld xmlns:a="http://schemas.openxmlformats.org/drawingml/2006/main" xmlns:p="http://schemas.openxmlformats.org/presentationml/2006/main" xmlns:r="http://schemas.openxmlformats.org/officeDocument/2006/relationships">
-  <p:cSld>
-    <p:spTree>
-      <p:nvGrpSpPr>
-        <p:cNvPr id="1" name=""/>
-        <p:cNvGrpSpPr/>
-        <p:nvPr/>
-      </p:nvGrpSpPr>
-      <p:grpSpPr/>
-      <p:pic>
-        <p:nvPicPr>
-          <p:cNvPr id="2" name="Picture 1" descr="image.jpg"/>
-          <p:cNvPicPr>
-            <a:picLocks noChangeAspect="1"/>
-          </p:cNvPicPr>
-          <p:nvPr/>
-        </p:nvPicPr>
-        <p:blipFill>
-          <a:blip r:embed="rId2"/>
-          <a:stretch>
-            <a:fillRect/>
-          </a:stretch>
-        </p:blipFill>
-        <p:spPr>
-          <a:xfrm>
-            <a:off x="1523999" y="1371600"/>
-            <a:ext cx="6096000" cy="3429000"/>
-          </a:xfrm>
-          <a:prstGeom prst="rect">
-            <a:avLst/>
-          </a:prstGeom>
-        </p:spPr>
-      </p:pic>
-      <p:sp>
-        <p:nvSpPr>
-          <p:cNvPr id="3" name="TextBox 2"/>
-          <p:cNvSpPr txBox="1"/>
-          <p:nvPr/>
-        </p:nvSpPr>
-        <p:spPr>
-          <a:xfrm>
-            <a:off x="914400" y="5943600"/>
-            <a:ext cx="7315200" cy="914400"/>
-          </a:xfrm>
-          <a:prstGeom prst="rect">
-            <a:avLst/>
-          </a:prstGeom>
-          <a:noFill/>
-        </p:spPr>
-        <p:txBody>
-          <a:bodyPr wrap="none">
-            <a:spAutoFit/>
-          </a:bodyPr>
-          <a:lstStyle/>
-          <a:p>
-            <a:r>
-              <a:t>8 Design Patterns EVERY Developer Should Know - 09:45:000</a:t>
+              <a:t>8 Design Patterns EVERY Developer Should Know - 09:36:000</a:t>
             </a:r>
           </a:p>
         </p:txBody>
@@ -5246,7 +3400,7 @@
           <a:lstStyle/>
           <a:p>
             <a:r>
-              <a:t>8 Design Patterns EVERY Developer Should Know - 07:51:000</a:t>
+              <a:t>8 Design Patterns EVERY Developer Should Know - 09:38:000</a:t>
             </a:r>
           </a:p>
         </p:txBody>
@@ -5316,7 +3470,7 @@
           <a:lstStyle/>
           <a:p>
             <a:r>
-              <a:t>8 Design Patterns EVERY Developer Should Know - 07:55:000</a:t>
+              <a:t>8 Design Patterns EVERY Developer Should Know - 09:39:000</a:t>
             </a:r>
           </a:p>
         </p:txBody>
@@ -5386,7 +3540,7 @@
           <a:lstStyle/>
           <a:p>
             <a:r>
-              <a:t>8 Design Patterns EVERY Developer Should Know - 08:16:000</a:t>
+              <a:t>8 Design Patterns EVERY Developer Should Know - 09:40:000</a:t>
             </a:r>
           </a:p>
         </p:txBody>
@@ -5456,7 +3610,7 @@
           <a:lstStyle/>
           <a:p>
             <a:r>
-              <a:t>8 Design Patterns EVERY Developer Should Know - 08:25:000</a:t>
+              <a:t>8 Design Patterns EVERY Developer Should Know - 09:41:000</a:t>
             </a:r>
           </a:p>
         </p:txBody>
@@ -5526,7 +3680,7 @@
           <a:lstStyle/>
           <a:p>
             <a:r>
-              <a:t>8 Design Patterns EVERY Developer Should Know - 08:28:000</a:t>
+              <a:t>8 Design Patterns EVERY Developer Should Know - 09:43:000</a:t>
             </a:r>
           </a:p>
         </p:txBody>
@@ -5596,7 +3750,7 @@
           <a:lstStyle/>
           <a:p>
             <a:r>
-              <a:t>8 Design Patterns EVERY Developer Should Know - 08:30:000</a:t>
+              <a:t>8 Design Patterns EVERY Developer Should Know - 09:44:000</a:t>
             </a:r>
           </a:p>
         </p:txBody>

</xml_diff>

<commit_message>
ConversionController sınıfının threading ve mesajlaşma sorumlulukları ayrıldı
</commit_message>
<xml_diff>
--- a/8_Design_Patterns_EVERY_Developer_Should_Know.pptx
+++ b/8_Design_Patterns_EVERY_Developer_Should_Know.pptx
@@ -12,9 +12,6 @@
     <p:sldId id="260" r:id="rId11"/>
     <p:sldId id="261" r:id="rId12"/>
     <p:sldId id="262" r:id="rId13"/>
-    <p:sldId id="263" r:id="rId14"/>
-    <p:sldId id="264" r:id="rId15"/>
-    <p:sldId id="265" r:id="rId16"/>
   </p:sldIdLst>
   <p:sldSz cx="9144000" cy="6858000" type="screen4x3"/>
   <p:notesSz cx="6858000" cy="9144000"/>
@@ -3161,76 +3158,6 @@
 </p:sld>
 </file>
 
-<file path=ppt/slides/slide10.xml><?xml version="1.0" encoding="utf-8"?>
-<p:sld xmlns:a="http://schemas.openxmlformats.org/drawingml/2006/main" xmlns:p="http://schemas.openxmlformats.org/presentationml/2006/main" xmlns:r="http://schemas.openxmlformats.org/officeDocument/2006/relationships">
-  <p:cSld>
-    <p:spTree>
-      <p:nvGrpSpPr>
-        <p:cNvPr id="1" name=""/>
-        <p:cNvGrpSpPr/>
-        <p:nvPr/>
-      </p:nvGrpSpPr>
-      <p:grpSpPr/>
-      <p:pic>
-        <p:nvPicPr>
-          <p:cNvPr id="2" name="Picture 1" descr="image.jpg"/>
-          <p:cNvPicPr>
-            <a:picLocks noChangeAspect="1"/>
-          </p:cNvPicPr>
-          <p:nvPr/>
-        </p:nvPicPr>
-        <p:blipFill>
-          <a:blip r:embed="rId2"/>
-          <a:stretch>
-            <a:fillRect/>
-          </a:stretch>
-        </p:blipFill>
-        <p:spPr>
-          <a:xfrm>
-            <a:off x="1523999" y="1371600"/>
-            <a:ext cx="6096000" cy="3429000"/>
-          </a:xfrm>
-          <a:prstGeom prst="rect">
-            <a:avLst/>
-          </a:prstGeom>
-        </p:spPr>
-      </p:pic>
-      <p:sp>
-        <p:nvSpPr>
-          <p:cNvPr id="3" name="TextBox 2"/>
-          <p:cNvSpPr txBox="1"/>
-          <p:nvPr/>
-        </p:nvSpPr>
-        <p:spPr>
-          <a:xfrm>
-            <a:off x="914400" y="5943600"/>
-            <a:ext cx="7315200" cy="914400"/>
-          </a:xfrm>
-          <a:prstGeom prst="rect">
-            <a:avLst/>
-          </a:prstGeom>
-          <a:noFill/>
-        </p:spPr>
-        <p:txBody>
-          <a:bodyPr wrap="none">
-            <a:spAutoFit/>
-          </a:bodyPr>
-          <a:lstStyle/>
-          <a:p>
-            <a:r>
-              <a:t>8 Design Patterns EVERY Developer Should Know - 09:45:000</a:t>
-            </a:r>
-          </a:p>
-        </p:txBody>
-      </p:sp>
-    </p:spTree>
-  </p:cSld>
-  <p:clrMapOvr>
-    <a:masterClrMapping/>
-  </p:clrMapOvr>
-</p:sld>
-</file>
-
 <file path=ppt/slides/slide2.xml><?xml version="1.0" encoding="utf-8"?>
 <p:sld xmlns:a="http://schemas.openxmlformats.org/drawingml/2006/main" xmlns:p="http://schemas.openxmlformats.org/presentationml/2006/main" xmlns:r="http://schemas.openxmlformats.org/officeDocument/2006/relationships">
   <p:cSld>
@@ -3250,7 +3177,7 @@
           <p:nvPr/>
         </p:nvPicPr>
         <p:blipFill>
-          <a:blip r:embed="rId2"/>
+          <a:blip r:embed="rId3"/>
           <a:stretch>
             <a:fillRect/>
           </a:stretch>
@@ -3330,7 +3257,7 @@
           <a:lstStyle/>
           <a:p>
             <a:r>
-              <a:t>8 Design Patterns EVERY Developer Should Know - 09:36:000</a:t>
+              <a:t>8 Design Patterns EVERY Developer Should Know - 09:40:000</a:t>
             </a:r>
           </a:p>
         </p:txBody>
@@ -3400,7 +3327,7 @@
           <a:lstStyle/>
           <a:p>
             <a:r>
-              <a:t>8 Design Patterns EVERY Developer Should Know - 09:38:000</a:t>
+              <a:t>8 Design Patterns EVERY Developer Should Know - 09:41:000</a:t>
             </a:r>
           </a:p>
         </p:txBody>
@@ -3470,7 +3397,7 @@
           <a:lstStyle/>
           <a:p>
             <a:r>
-              <a:t>8 Design Patterns EVERY Developer Should Know - 09:39:000</a:t>
+              <a:t>8 Design Patterns EVERY Developer Should Know - 09:43:000</a:t>
             </a:r>
           </a:p>
         </p:txBody>
@@ -3540,7 +3467,7 @@
           <a:lstStyle/>
           <a:p>
             <a:r>
-              <a:t>8 Design Patterns EVERY Developer Should Know - 09:40:000</a:t>
+              <a:t>8 Design Patterns EVERY Developer Should Know - 09:44:000</a:t>
             </a:r>
           </a:p>
         </p:txBody>
@@ -3610,147 +3537,7 @@
           <a:lstStyle/>
           <a:p>
             <a:r>
-              <a:t>8 Design Patterns EVERY Developer Should Know - 09:41:000</a:t>
-            </a:r>
-          </a:p>
-        </p:txBody>
-      </p:sp>
-    </p:spTree>
-  </p:cSld>
-  <p:clrMapOvr>
-    <a:masterClrMapping/>
-  </p:clrMapOvr>
-</p:sld>
-</file>
-
-<file path=ppt/slides/slide8.xml><?xml version="1.0" encoding="utf-8"?>
-<p:sld xmlns:a="http://schemas.openxmlformats.org/drawingml/2006/main" xmlns:p="http://schemas.openxmlformats.org/presentationml/2006/main" xmlns:r="http://schemas.openxmlformats.org/officeDocument/2006/relationships">
-  <p:cSld>
-    <p:spTree>
-      <p:nvGrpSpPr>
-        <p:cNvPr id="1" name=""/>
-        <p:cNvGrpSpPr/>
-        <p:nvPr/>
-      </p:nvGrpSpPr>
-      <p:grpSpPr/>
-      <p:pic>
-        <p:nvPicPr>
-          <p:cNvPr id="2" name="Picture 1" descr="image.jpg"/>
-          <p:cNvPicPr>
-            <a:picLocks noChangeAspect="1"/>
-          </p:cNvPicPr>
-          <p:nvPr/>
-        </p:nvPicPr>
-        <p:blipFill>
-          <a:blip r:embed="rId2"/>
-          <a:stretch>
-            <a:fillRect/>
-          </a:stretch>
-        </p:blipFill>
-        <p:spPr>
-          <a:xfrm>
-            <a:off x="1523999" y="1371600"/>
-            <a:ext cx="6096000" cy="3429000"/>
-          </a:xfrm>
-          <a:prstGeom prst="rect">
-            <a:avLst/>
-          </a:prstGeom>
-        </p:spPr>
-      </p:pic>
-      <p:sp>
-        <p:nvSpPr>
-          <p:cNvPr id="3" name="TextBox 2"/>
-          <p:cNvSpPr txBox="1"/>
-          <p:nvPr/>
-        </p:nvSpPr>
-        <p:spPr>
-          <a:xfrm>
-            <a:off x="914400" y="5943600"/>
-            <a:ext cx="7315200" cy="914400"/>
-          </a:xfrm>
-          <a:prstGeom prst="rect">
-            <a:avLst/>
-          </a:prstGeom>
-          <a:noFill/>
-        </p:spPr>
-        <p:txBody>
-          <a:bodyPr wrap="none">
-            <a:spAutoFit/>
-          </a:bodyPr>
-          <a:lstStyle/>
-          <a:p>
-            <a:r>
-              <a:t>8 Design Patterns EVERY Developer Should Know - 09:43:000</a:t>
-            </a:r>
-          </a:p>
-        </p:txBody>
-      </p:sp>
-    </p:spTree>
-  </p:cSld>
-  <p:clrMapOvr>
-    <a:masterClrMapping/>
-  </p:clrMapOvr>
-</p:sld>
-</file>
-
-<file path=ppt/slides/slide9.xml><?xml version="1.0" encoding="utf-8"?>
-<p:sld xmlns:a="http://schemas.openxmlformats.org/drawingml/2006/main" xmlns:p="http://schemas.openxmlformats.org/presentationml/2006/main" xmlns:r="http://schemas.openxmlformats.org/officeDocument/2006/relationships">
-  <p:cSld>
-    <p:spTree>
-      <p:nvGrpSpPr>
-        <p:cNvPr id="1" name=""/>
-        <p:cNvGrpSpPr/>
-        <p:nvPr/>
-      </p:nvGrpSpPr>
-      <p:grpSpPr/>
-      <p:pic>
-        <p:nvPicPr>
-          <p:cNvPr id="2" name="Picture 1" descr="image.jpg"/>
-          <p:cNvPicPr>
-            <a:picLocks noChangeAspect="1"/>
-          </p:cNvPicPr>
-          <p:nvPr/>
-        </p:nvPicPr>
-        <p:blipFill>
-          <a:blip r:embed="rId2"/>
-          <a:stretch>
-            <a:fillRect/>
-          </a:stretch>
-        </p:blipFill>
-        <p:spPr>
-          <a:xfrm>
-            <a:off x="1523999" y="1371600"/>
-            <a:ext cx="6096000" cy="3429000"/>
-          </a:xfrm>
-          <a:prstGeom prst="rect">
-            <a:avLst/>
-          </a:prstGeom>
-        </p:spPr>
-      </p:pic>
-      <p:sp>
-        <p:nvSpPr>
-          <p:cNvPr id="3" name="TextBox 2"/>
-          <p:cNvSpPr txBox="1"/>
-          <p:nvPr/>
-        </p:nvSpPr>
-        <p:spPr>
-          <a:xfrm>
-            <a:off x="914400" y="5943600"/>
-            <a:ext cx="7315200" cy="914400"/>
-          </a:xfrm>
-          <a:prstGeom prst="rect">
-            <a:avLst/>
-          </a:prstGeom>
-          <a:noFill/>
-        </p:spPr>
-        <p:txBody>
-          <a:bodyPr wrap="none">
-            <a:spAutoFit/>
-          </a:bodyPr>
-          <a:lstStyle/>
-          <a:p>
-            <a:r>
-              <a:t>8 Design Patterns EVERY Developer Should Know - 09:44:000</a:t>
+              <a:t>8 Design Patterns EVERY Developer Should Know - 09:45:000</a:t>
             </a:r>
           </a:p>
         </p:txBody>

</xml_diff>